<commit_message>
docs(help): tutorial deck updated for main ee9679a (SSMA corrective action fix, pending items)
Co-Authored-By: Claude Sonnet 5.5 <noreply@anthropic.com>
</commit_message>
<xml_diff>
--- a/apps/web/content/tutorial/ACC-apresentacao-e-tutorial.pptx
+++ b/apps/web/content/tutorial/ACC-apresentacao-e-tutorial.pptx
@@ -3686,7 +3686,7 @@
                 <a:ea typeface="Calibri" pitchFamily="34" charset="-122"/>
                 <a:cs typeface="Calibri" pitchFamily="34" charset="-120"/>
               </a:rPr>
-              <a:t>Versão publicada em produção em 27/10/2026 (main 44571fe) · acc.axion.com.br</a:t>
+              <a:t>Versão publicada em produção em 27/10/2026 (main ee9679a) · acc.axion.com.br</a:t>
             </a:r>
             <a:endParaRPr lang="en-US" sz="1400" dirty="0"/>
           </a:p>
@@ -20040,7 +20040,7 @@
                 <a:ea typeface="Calibri" pitchFamily="34" charset="-122"/>
                 <a:cs typeface="Calibri" pitchFamily="34" charset="-120"/>
               </a:rPr>
-              <a:t>na versão publicada (44571fe) a ação corretiva ainda não aparece por um defeito já corrigido em branch, aguardando publicação (slide 23).</a:t>
+              <a:t>a ação corretiva aparecia como "Sem ação" por um defeito, corrigido na publicação ee9679a. A correção foi verificada em ambiente de teste com dados fictícios (slide 23); a conferência com a conta real em produção ainda será feita.</a:t>
             </a:r>
             <a:endParaRPr lang="en-US" sz="1300" dirty="0"/>
           </a:p>
@@ -21363,7 +21363,7 @@
         </p:nvSpPr>
         <p:spPr>
           <a:xfrm>
-            <a:off x="1336226" y="1630192"/>
+            <a:off x="1405424" y="1836572"/>
             <a:ext cx="274320" cy="274320"/>
           </a:xfrm>
           <a:prstGeom prst="ellipse">
@@ -21388,7 +21388,7 @@
         </p:nvSpPr>
         <p:spPr>
           <a:xfrm>
-            <a:off x="1336226" y="1630192"/>
+            <a:off x="1405424" y="1836572"/>
             <a:ext cx="274320" cy="274320"/>
           </a:xfrm>
           <a:prstGeom prst="rect">
@@ -21491,7 +21491,7 @@
         </p:nvSpPr>
         <p:spPr>
           <a:xfrm>
-            <a:off x="537296" y="3494380"/>
+            <a:off x="3053610" y="2716225"/>
             <a:ext cx="274320" cy="274320"/>
           </a:xfrm>
           <a:prstGeom prst="ellipse">
@@ -21516,7 +21516,7 @@
         </p:nvSpPr>
         <p:spPr>
           <a:xfrm>
-            <a:off x="537296" y="3494380"/>
+            <a:off x="3053610" y="2716225"/>
             <a:ext cx="274320" cy="274320"/>
           </a:xfrm>
           <a:prstGeom prst="rect">
@@ -21555,7 +21555,7 @@
         </p:nvSpPr>
         <p:spPr>
           <a:xfrm>
-            <a:off x="4110462" y="3521446"/>
+            <a:off x="3682689" y="2716225"/>
             <a:ext cx="274320" cy="274320"/>
           </a:xfrm>
           <a:prstGeom prst="ellipse">
@@ -21580,7 +21580,7 @@
         </p:nvSpPr>
         <p:spPr>
           <a:xfrm>
-            <a:off x="4110462" y="3521446"/>
+            <a:off x="3682689" y="2716225"/>
             <a:ext cx="274320" cy="274320"/>
           </a:xfrm>
           <a:prstGeom prst="rect">
@@ -21619,7 +21619,7 @@
         </p:nvSpPr>
         <p:spPr>
           <a:xfrm>
-            <a:off x="6092060" y="3521446"/>
+            <a:off x="6073188" y="2716225"/>
             <a:ext cx="274320" cy="274320"/>
           </a:xfrm>
           <a:prstGeom prst="ellipse">
@@ -21644,7 +21644,7 @@
         </p:nvSpPr>
         <p:spPr>
           <a:xfrm>
-            <a:off x="6092060" y="3521446"/>
+            <a:off x="6073188" y="2716225"/>
             <a:ext cx="274320" cy="274320"/>
           </a:xfrm>
           <a:prstGeom prst="rect">
@@ -22254,7 +22254,7 @@
                 <a:ea typeface="Calibri" pitchFamily="34" charset="-122"/>
                 <a:cs typeface="Calibri" pitchFamily="34" charset="-120"/>
               </a:rPr>
-              <a:t>na versão publicada mostra "Sem ação" por um defeito (veja o aviso)</a:t>
+              <a:t>Aberta, Em atraso ou Concluída</a:t>
             </a:r>
             <a:endParaRPr lang="en-US" sz="1300" dirty="0"/>
           </a:p>
@@ -22320,7 +22320,7 @@
                 <a:ea typeface="Calibri" pitchFamily="34" charset="-122"/>
                 <a:cs typeface="Calibri" pitchFamily="34" charset="-120"/>
               </a:rPr>
-              <a:t>Defeito conhecido na versão publicada (44571fe): a ação corretiva não aparece na lista nem no detalhe, e o andamento não pode ser registrado pelo app. Correção pronta e testada em branch (fix/ssma-corrective-action-embed), ainda não publicada.</a:t>
+              <a:t>Defeito corrigido: até a versão 44571fe a ação corretiva aparecia como "Sem ação" e o andamento não podia ser registrado pelo app. A correção foi publicada em ee9679a e verificada em ambiente de teste com dados fictícios (esta imagem). A conferência com a conta real em produção ainda não foi feita.</a:t>
             </a:r>
             <a:endParaRPr lang="en-US" sz="1300" dirty="0"/>
           </a:p>
@@ -22386,7 +22386,7 @@
                 <a:ea typeface="Calibri" pitchFamily="34" charset="-122"/>
                 <a:cs typeface="Calibri" pitchFamily="34" charset="-120"/>
               </a:rPr>
-              <a:t>Código real da main (44571fe) · dados fictícios · ambiente local, desktop 1440 px — não é a produção</a:t>
+              <a:t>Código real da main (ee9679a, com a correção do SSMA) · dados fictícios · ambiente local, desktop 1440 px — não é a produção</a:t>
             </a:r>
             <a:endParaRPr lang="en-US" sz="1100" dirty="0"/>
           </a:p>
@@ -24900,7 +24900,7 @@
                 <a:ea typeface="Calibri" pitchFamily="34" charset="-122"/>
                 <a:cs typeface="Calibri" pitchFamily="34" charset="-120"/>
               </a:rPr>
-              <a:t>Este material (PDF para consulta e PowerPoint editável) está preparado como a entrada "Ajuda e tutorial" no menu da obra.</a:t>
+              <a:t>Este material (PDF para consulta e PowerPoint editável) fica na entrada "Ajuda e tutorial" do menu lateral da obra.</a:t>
             </a:r>
             <a:endParaRPr lang="en-US" sz="1500" dirty="0"/>
           </a:p>
@@ -24942,7 +24942,7 @@
                 <a:ea typeface="Calibri" pitchFamily="34" charset="-122"/>
                 <a:cs typeface="Calibri" pitchFamily="34" charset="-120"/>
               </a:rPr>
-              <a:t>A entrada entra em produção junto com a próxima publicação aprovada; até lá o material é distribuído pelo PDF e pelo PowerPoint.</a:t>
+              <a:t>No PDF, o arquivo abre na própria aba; o PowerPoint é baixado para edição.</a:t>
             </a:r>
             <a:endParaRPr lang="en-US" sz="1500" dirty="0"/>
           </a:p>
@@ -25313,7 +25313,31 @@
                           <a:ea typeface="Calibri" pitchFamily="34" charset="-122"/>
                           <a:cs typeface="Calibri" pitchFamily="34" charset="-120"/>
                         </a:rPr>
-                        <a:t>Código publicado na main (44571fe); deploy de produção READY em acc.axion.com.br</a:t>
+                        <a:t>Código publicado na main (ee9679a); deploy de produção READY em acc.axion.com.br</a:t>
+                      </a:r>
+                      <a:endParaRPr lang="en-US" sz="1500" dirty="0">
+                        <a:latin typeface="Calibri" charset="0"/>
+                        <a:ea typeface="Calibri" charset="0"/>
+                        <a:cs typeface="Calibri" charset="0"/>
+                      </a:endParaRPr>
+                    </a:p>
+                    <a:p>
+                      <a:pPr indent="0" marL="0">
+                        <a:spcAft>
+                          <a:spcPts val="800"/>
+                        </a:spcAft>
+                        <a:buNone/>
+                      </a:pPr>
+                      <a:r>
+                        <a:rPr lang="en-US" sz="1500" dirty="0">
+                          <a:solidFill>
+                            <a:srgbClr val="1F2937"/>
+                          </a:solidFill>
+                          <a:latin typeface="Calibri" pitchFamily="34" charset="0"/>
+                          <a:ea typeface="Calibri" pitchFamily="34" charset="-122"/>
+                          <a:cs typeface="Calibri" pitchFamily="34" charset="-120"/>
+                        </a:rPr>
+                        <a:t>Correção do SSMA (ação corretiva) verificada em ambiente de teste, dados fictícios</a:t>
                       </a:r>
                       <a:endParaRPr lang="en-US" sz="1500" dirty="0">
                         <a:latin typeface="Calibri" charset="0"/>
@@ -25581,6 +25605,30 @@
                         <a:cs typeface="Calibri" charset="0"/>
                       </a:endParaRPr>
                     </a:p>
+                    <a:p>
+                      <a:pPr indent="0" marL="0">
+                        <a:spcAft>
+                          <a:spcPts val="800"/>
+                        </a:spcAft>
+                        <a:buNone/>
+                      </a:pPr>
+                      <a:r>
+                        <a:rPr lang="en-US" sz="1500" dirty="0">
+                          <a:solidFill>
+                            <a:srgbClr val="1F2937"/>
+                          </a:solidFill>
+                          <a:latin typeface="Calibri" pitchFamily="34" charset="0"/>
+                          <a:ea typeface="Calibri" pitchFamily="34" charset="-122"/>
+                          <a:cs typeface="Calibri" pitchFamily="34" charset="-120"/>
+                        </a:rPr>
+                        <a:t>Ação corretiva do SSMA com conta real em produção</a:t>
+                      </a:r>
+                      <a:endParaRPr lang="en-US" sz="1500" dirty="0">
+                        <a:latin typeface="Calibri" charset="0"/>
+                        <a:ea typeface="Calibri" charset="0"/>
+                        <a:cs typeface="Calibri" charset="0"/>
+                      </a:endParaRPr>
+                    </a:p>
                   </a:txBody>
                   <a:tcPr marL="91440" marR="91440" marT="45720" marB="45720" anchor="t">
                     <a:lnL w="12700" cap="flat" cmpd="sng" algn="ctr">
@@ -27236,7 +27284,7 @@
                 <a:ea typeface="Calibri" pitchFamily="34" charset="-122"/>
                 <a:cs typeface="Calibri" pitchFamily="34" charset="-120"/>
               </a:rPr>
-              <a:t>Todas as imagens usam o código publicado na main (44571fe) e dados fictícios ("Obra Exemplo ACC"). Nenhuma imagem mostra dados reais de contrato. Cada imagem informa sua procedência:</a:t>
+              <a:t>Todas as imagens usam o código da main (44571fe; a tela do SSMA já inclui a correção publicada em ee9679a) e dados fictícios ("Obra Exemplo ACC"). Nenhuma imagem mostra dados reais de contrato. Cada imagem informa sua procedência:</a:t>
             </a:r>
             <a:endParaRPr lang="en-US" sz="1600" dirty="0"/>
           </a:p>

</xml_diff>